<commit_message>
﻿Document the ZIP lookup across deck, README and notes
The docs still described a duty-station-only dropdown of 338 areas, which is
no longer what the app does. Updated the guide deck, the README feature list
and the maintainer notes.

The notes now cover why ZIP exists, how the packed range table is encoded and
searched, why a failed lookup zeroes the field, why the mode has to round-trip
in shared links, and why county cost groups are absent from the dropdown but
still reachable by ZIP.

Added the ZIP regeneration step to the yearly update procedure - it is in the
same DoD bundle and changes every year, so it would have been easy to miss.
</commit_message>
<xml_diff>
--- a/Military-Pay-Estimator-Guide.pptx
+++ b/Military-Pay-Estimator-Guide.pptx
@@ -3819,7 +3819,7 @@
                 <a:ea typeface="Calibri" pitchFamily="34" charset="-122"/>
                 <a:cs typeface="Calibri" pitchFamily="34" charset="-120"/>
               </a:rPr>
-              <a:t>Defense Travel Management Office — 338 housing areas, every rank</a:t>
+              <a:t>Defense Travel Management Office — every housing area and rank, plus the official ZIP lookup</a:t>
             </a:r>
             <a:endParaRPr lang="en-US" sz="1200" dirty="0"/>
           </a:p>
@@ -12366,7 +12366,7 @@
                 <a:ea typeface="Cambria" pitchFamily="34" charset="-122"/>
                 <a:cs typeface="Cambria" pitchFamily="34" charset="-120"/>
               </a:rPr>
-              <a:t>Duty station</a:t>
+              <a:t>Duty station or ZIP</a:t>
             </a:r>
             <a:endParaRPr lang="en-US" sz="1400" dirty="0"/>
           </a:p>
@@ -12405,7 +12405,7 @@
                 <a:ea typeface="Calibri" pitchFamily="34" charset="-122"/>
                 <a:cs typeface="Calibri" pitchFamily="34" charset="-120"/>
               </a:rPr>
-              <a:t>338 real housing areas. Picking one fills in your housing allowance automatically.</a:t>
+              <a:t>Pick a station, or switch to ZIP — useful when home of record is away from the duty station. Either fills the housing allowance.</a:t>
             </a:r>
             <a:endParaRPr lang="en-US" sz="1150" dirty="0"/>
           </a:p>

</xml_diff>

<commit_message>
﻿Keep the new deck lines within a length that is known to fit
The ZIP documentation pass pushed three lines well past their neighbours -
128, 92 and 90 characters where every verified row in the same fixed-height
cards sits between 25 and 75. A previous text change in these cards clipped,
and no renderer was available to check this one, so the lines are trimmed back
into the range that has already been shown to lay out correctly.

Meaning is unchanged: the ZIP option, the DTMO source and the privacy answer
all still say what they said.
</commit_message>
<xml_diff>
--- a/Military-Pay-Estimator-Guide.pptx
+++ b/Military-Pay-Estimator-Guide.pptx
@@ -3819,7 +3819,7 @@
                 <a:ea typeface="Calibri" pitchFamily="34" charset="-122"/>
                 <a:cs typeface="Calibri" pitchFamily="34" charset="-120"/>
               </a:rPr>
-              <a:t>Defense Travel Management Office — every housing area and rank, plus the official ZIP lookup</a:t>
+              <a:t>Defense Travel Management Office — all areas, ranks, and the ZIP map</a:t>
             </a:r>
             <a:endParaRPr lang="en-US" sz="1200" dirty="0"/>
           </a:p>
@@ -6474,7 +6474,7 @@
                 <a:ea typeface="Calibri" pitchFamily="34" charset="-122"/>
                 <a:cs typeface="Calibri" pitchFamily="34" charset="-120"/>
               </a:rPr>
-              <a:t>No. Your pay details never leave your browser. The feedback form is separate and optional.</a:t>
+              <a:t>No. Pay details stay in your browser; the feedback form is separate.</a:t>
             </a:r>
             <a:endParaRPr lang="en-US" sz="1250" dirty="0"/>
           </a:p>
@@ -12405,7 +12405,7 @@
                 <a:ea typeface="Calibri" pitchFamily="34" charset="-122"/>
                 <a:cs typeface="Calibri" pitchFamily="34" charset="-120"/>
               </a:rPr>
-              <a:t>Pick a station, or switch to ZIP — useful when home of record is away from the duty station. Either fills the housing allowance.</a:t>
+              <a:t>Pick a station, or switch to ZIP if you live away from your duty station.</a:t>
             </a:r>
             <a:endParaRPr lang="en-US" sz="1150" dirty="0"/>
           </a:p>

</xml_diff>